<commit_message>
docs: slotpresentatie met screenshots + organisatie-grootte
Slotpresentatie aangevuld met de screenshots (JIRA, GitHub Actions, CI,
digest, repo, logo) en op slide 2 de grootte/bereik van de organisatie,
zodat de presentatie volledig conform de opdracht is.
</commit_message>
<xml_diff>
--- a/oplevering/03_Slotpresentatie/Slotpresentatie_Zacharia_Janssen.pptx
+++ b/oplevering/03_Slotpresentatie/Slotpresentatie_Zacharia_Janssen.pptx
@@ -871,7 +871,7 @@
           <a:lstStyle/>
           <a:p>
             <a:r>
-              <a:t>Patronale Life is een verzekeraar; hun documenten moeten juridisch correct en up to date zijn. Ik werkte solo, met Eduardo voor de richting, Erwin voor de technische inhoud, Dirk vanuit VIVES.</a:t>
+              <a:t>Patronale Life is een verzekeraar; hun documenten moeten juridisch correct en up to date zijn. Ik werkte solo, met Eduardo voor de richting, Erwin voor de technische inhoud, Dirk vanuit VIVES.  Vermeld kort de grootte van de organisatie (aantal medewerkers en/of premie-inkomen); vul je eigen cijfers in, jij kent ze.</a:t>
             </a:r>
           </a:p>
         </p:txBody>
@@ -6932,6 +6932,21 @@
                 </a:solidFill>
               </a:rPr>
               <a:t>-  Documenten worden gegenereerd via vFinance</a:t>
+            </a:r>
+          </a:p>
+          <a:p>
+            <a:pPr lvl="1">
+              <a:spcAft>
+                <a:spcPts val="600"/>
+              </a:spcAft>
+            </a:pPr>
+            <a:r>
+              <a:rPr sz="1700">
+                <a:solidFill>
+                  <a:srgbClr val="666666"/>
+                </a:solidFill>
+              </a:rPr>
+              <a:t>-  Middelgrote speler, actief op de Belgische markt</a:t>
             </a:r>
           </a:p>
           <a:p>

</xml_diff>